<commit_message>
Revise egress documentation and scripts to enhance clarity on multi-cluster connectivity. Updated `decks.js` to reflect new findings on private subdomains and east-west traffic strategies. Enhanced `README.md` with details on OpenShift cluster destinations and their implications. Modified `run-escenarios.sh` to support testing against real OpenShift destinations, improving scenario reliability. Updated `RESUMEN.md` to summarize key changes and strategies for token audience management.
</commit_message>
<xml_diff>
--- a/poc-egress-kuadrant/poc-egreso-kuadrant-tecnica-2026-08.pptx
+++ b/poc-egress-kuadrant/poc-egreso-kuadrant-tecnica-2026-08.pptx
@@ -2518,7 +2518,7 @@
                 <a:ea typeface="Cambria" pitchFamily="34" charset="-122"/>
                 <a:cs typeface="Cambria" pitchFamily="34" charset="-120"/>
               </a:rPr>
-              <a:t>Red hacia el destino</a:t>
+              <a:t>Subdominio privado y tráfico east-west</a:t>
             </a:r>
             <a:endParaRPr lang="en-US" sz="1800" dirty="0"/>
           </a:p>
@@ -2560,7 +2560,7 @@
                 <a:ea typeface="Calibri" pitchFamily="34" charset="-122"/>
                 <a:cs typeface="Calibri" pitchFamily="34" charset="-120"/>
               </a:rPr>
-              <a:t>Bloqueante para cualquier prueba real. Habilitar el puerto 443 desde la subred de workers, o fijar una IP de egreso.</a:t>
+              <a:t>Hoy el salto usa la zona de publicación de aplicaciones, con nombres de laboratorio. Hace falta una zona interna dedicada al tráfico entre clusters: convención de nombres, emisión de certificados y resolución desde CoreDNS.</a:t>
             </a:r>
             <a:endParaRPr lang="en-US" sz="1400" dirty="0"/>
           </a:p>
@@ -2663,7 +2663,7 @@
                 <a:ea typeface="Cambria" pitchFamily="34" charset="-122"/>
                 <a:cs typeface="Cambria" pitchFamily="34" charset="-120"/>
               </a:rPr>
-              <a:t>Rotación de clave y observabilidad</a:t>
+              <a:t>Rotación, audiencia desacoplada y observabilidad</a:t>
             </a:r>
             <a:endParaRPr lang="en-US" sz="1800" dirty="0"/>
           </a:p>
@@ -2705,7 +2705,7 @@
                 <a:ea typeface="Calibri" pitchFamily="34" charset="-122"/>
                 <a:cs typeface="Calibri" pitchFamily="34" charset="-120"/>
               </a:rPr>
-              <a:t>Un identificador de audiencia por destino, rotación sin ventana, y métricas por backend — que además son el criterio para avanzar de fase.</a:t>
+              <a:t>Hoy la audiencia del token ES el FQDN, así que renombrar el dominio rompe el contrato. Va junto con el punto 3. Más rotación sin ventana y métricas por backend.</a:t>
             </a:r>
             <a:endParaRPr lang="en-US" sz="1400" dirty="0"/>
           </a:p>

</xml_diff>